<commit_message>
chore(release,docs): 乾淨 clone 重建腳本 scripts/release/clean-build.sh（COMP-07／R01）；參賽計畫 §3 狀態同步；demo-video §8 v4 五段 170 秒配置含 SKR 段與 No-go 替代稿；judges-guide SKR／可重建說明；README／PG 同步
Co-Authored-By: Claude Opus 5 <noreply@anthropic.com>
</commit_message>
<xml_diff>
--- a/output/hackathon-flexclip-en/NeonShift_Hackathon_EN.pptx
+++ b/output/hackathon-flexclip-en/NeonShift_Hackathon_EN.pptx
@@ -610,7 +610,7 @@
           </a:p>
           <a:p>
             <a:r>
-              <a:t>Start with a walk or a run. Our next design adds a personal Activity journal with monthly views and workout details. Choose automatic sync when online, with saved workouts processed oldest first. Starter shoes and level upgrades remain free.</a:t>
+              <a:t>Start with a walk or a run. The app now includes a personal Activity journal with monthly views and workout details. Choose automatic sync when online, with saved workouts processed oldest first. Starter shoes and level upgrades remain free.</a:t>
             </a:r>
           </a:p>
           <a:p/>
@@ -794,7 +794,7 @@
           </a:p>
           <a:p>
             <a:r>
-              <a:t>As you level up, discover Wild Guardians, inspired by threatened wildlife. Our next design lets you switch between shoes you have earned, with matching forest or ocean backgrounds. Prefer a simpler view? Turn the background off. These choices are cosmetic; your active level still controls eligibility. Each shoe connects your progress with conservation learning.</a:t>
+              <a:t>As you level up, discover Wild Guardians, inspired by threatened wildlife. The app now lets you switch between shoes you have earned, with matching forest or ocean backgrounds. Prefer a simpler view? Turn the background off. These choices are cosmetic; your active level still controls eligibility. Each shoe connects your progress with conservation learning.</a:t>
             </a:r>
           </a:p>
           <a:p/>
@@ -805,7 +805,7 @@
           </a:p>
           <a:p>
             <a:r>
-              <a:t>本頁使用專案既有鞋款素材；多鞋切換、森林／海洋背景與關閉開關為待實作設計。正式影片補切兩雙已取得鞋→關背景→故事卡；圖不可冒充實機。使用試拆時標 DEMO PREVIEW，切帳號標 Prepared demo account。不稱隨機 NFT、付費抽獎或保育收益權。</a:t>
+              <a:t>本頁使用專案既有鞋款素材；多鞋切換、森林／海洋背景與關閉開關已有程式；本頁仍是示意，提交版本實機待驗收。正式影片補切兩雙已取得鞋→關背景→故事卡；圖不可冒充實機。使用試拆時標 DEMO PREVIEW，切帳號標 Prepared demo account。不稱隨機 NFT、付費抽獎或保育收益權。</a:t>
             </a:r>
           </a:p>
         </p:txBody>
@@ -5516,7 +5516,7 @@
                 </a:solidFill>
                 <a:latin typeface="Arial"/>
               </a:rPr>
-              <a:t>DESIGN PREVIEW · SAMPLE DATA · IMPLEMENTATION PENDING</a:t>
+              <a:t>DESIGN PREVIEW · SAMPLE DATA · DEVICE VALIDATION PENDING</a:t>
             </a:r>
           </a:p>
         </p:txBody>

</xml_diff>